<commit_message>
M5: align Contoh #2 (and PPT/PDF) to Klasifikasi Pesan DM/WA, matching the realigned latihan file
</commit_message>
<xml_diff>
--- a/K2-Produktivitas/M05-Batch-Prompting/K2-M05-Batch-Prompting.pptx
+++ b/K2-Produktivitas/M05-Batch-Prompting/K2-M05-Batch-Prompting.pptx
@@ -2651,7 +2651,7 @@
                 <a:ea typeface="Helvetica" pitchFamily="34" charset="-122"/>
                 <a:cs typeface="Helvetica" pitchFamily="34" charset="-120"/>
               </a:rPr>
-              <a:t>Kategori Review</a:t>
+              <a:t>Klasifikasi Pesan (DM/WA)</a:t>
             </a:r>
             <a:endParaRPr lang="en-US" sz="1300" dirty="0"/>
           </a:p>
@@ -2693,7 +2693,7 @@
                 <a:ea typeface="Helvetica" pitchFamily="34" charset="-122"/>
                 <a:cs typeface="Helvetica" pitchFamily="34" charset="-120"/>
               </a:rPr>
-              <a:t>"Kategorikan tiap review: POSITIF/NEGATIF/NETRAL. Ekstrak poin utama maks 5 kata. Review: 1. 'Baju bagus, jahitan rapi...'"</a:t>
+              <a:t>"Klasifikasikan tiap pesan: KOMPLAIN/PERTANYAAN/PUJIAN/PERMINTAAN + urgensi. Pesan: 1. 'Halo, saya mau tanya paket kelola Instagram berapa ya?'"</a:t>
             </a:r>
             <a:endParaRPr lang="en-US" sz="1100" dirty="0"/>
           </a:p>

</xml_diff>

<commit_message>
M5 PPT: match intro wording to HTML (merged Apa itu + example, drop duplicate closing line)
</commit_message>
<xml_diff>
--- a/K2-Produktivitas/M05-Batch-Prompting/K2-M05-Batch-Prompting.pptx
+++ b/K2-Produktivitas/M05-Batch-Prompting/K2-M05-Batch-Prompting.pptx
@@ -1739,7 +1739,7 @@
         <p:spPr>
           <a:xfrm>
             <a:off x="548640" y="2112264"/>
-            <a:ext cx="11094415" cy="498734"/>
+            <a:ext cx="11094415" cy="959104"/>
           </a:xfrm>
           <a:prstGeom prst="rect">
             <a:avLst/>
@@ -1758,7 +1758,7 @@
               <a:buNone/>
             </a:pPr>
             <a:r>
-              <a:rPr lang="en-US" sz="1300" dirty="0">
+              <a:rPr lang="en-US" sz="1250" dirty="0">
                 <a:solidFill>
                   <a:srgbClr val="23283A"/>
                 </a:solidFill>
@@ -1766,9 +1766,9 @@
                 <a:ea typeface="Helvetica" pitchFamily="34" charset="-122"/>
                 <a:cs typeface="Helvetica" pitchFamily="34" charset="-120"/>
               </a:rPr>
-              <a:t>Kamu berikan Claude satu set instruksi + daftar item — Claude proses semua sekaligus. Berlaku untuk item apapun yang butuh perlakuan sama: deskripsi produk, ringkasan review, balasan template, kategori data, dll.</a:t>
-            </a:r>
-            <a:endParaRPr lang="en-US" sz="1300" dirty="0"/>
+              <a:t>Batch prompting adalah cara memberi Claude satu set instruksi + daftar item sekaligus, supaya semuanya diproses dalam satu kali jalan — bukan satu per satu secara manual. Cocok untuk pekerjaan apapun yang butuh perlakuan sama di banyak item: deskripsi produk, ringkasan review, balasan template, kategori data, dan sejenisnya. Contohnya: 20 item yang butuh diproses satu-satu — dengan cara biasa: 20 prompt terpisah, 20 copy-paste, 40 menit. Dengan batch prompting: 1 prompt, 20 hasil, 5 menit.</a:t>
+            </a:r>
+            <a:endParaRPr lang="en-US" sz="1250" dirty="0"/>
           </a:p>
         </p:txBody>
       </p:sp>
@@ -1780,7 +1780,7 @@
         </p:nvSpPr>
         <p:spPr>
           <a:xfrm>
-            <a:off x="548640" y="2867030"/>
+            <a:off x="548640" y="3327400"/>
             <a:ext cx="11094415" cy="2416835"/>
           </a:xfrm>
           <a:prstGeom prst="roundRect">
@@ -1807,7 +1807,7 @@
         </p:nvSpPr>
         <p:spPr>
           <a:xfrm>
-            <a:off x="768096" y="3086486"/>
+            <a:off x="768096" y="3546856"/>
             <a:ext cx="10655503" cy="256032"/>
           </a:xfrm>
           <a:prstGeom prst="rect">
@@ -1846,7 +1846,7 @@
         </p:nvSpPr>
         <p:spPr>
           <a:xfrm>
-            <a:off x="768096" y="3433958"/>
+            <a:off x="768096" y="3894328"/>
             <a:ext cx="10655503" cy="219456"/>
           </a:xfrm>
           <a:prstGeom prst="rect">
@@ -1885,7 +1885,7 @@
         </p:nvSpPr>
         <p:spPr>
           <a:xfrm>
-            <a:off x="768096" y="3689990"/>
+            <a:off x="768096" y="4150360"/>
             <a:ext cx="10655503" cy="214300"/>
           </a:xfrm>
           <a:prstGeom prst="rect">
@@ -1927,7 +1927,7 @@
         </p:nvSpPr>
         <p:spPr>
           <a:xfrm>
-            <a:off x="768096" y="4014018"/>
+            <a:off x="768096" y="4474388"/>
             <a:ext cx="10655503" cy="219456"/>
           </a:xfrm>
           <a:prstGeom prst="rect">
@@ -1966,7 +1966,7 @@
         </p:nvSpPr>
         <p:spPr>
           <a:xfrm>
-            <a:off x="768096" y="4270050"/>
+            <a:off x="768096" y="4730420"/>
             <a:ext cx="10655503" cy="214300"/>
           </a:xfrm>
           <a:prstGeom prst="rect">
@@ -2008,7 +2008,7 @@
         </p:nvSpPr>
         <p:spPr>
           <a:xfrm>
-            <a:off x="768096" y="4594078"/>
+            <a:off x="768096" y="5054448"/>
             <a:ext cx="10655503" cy="219456"/>
           </a:xfrm>
           <a:prstGeom prst="rect">
@@ -2047,7 +2047,7 @@
         </p:nvSpPr>
         <p:spPr>
           <a:xfrm>
-            <a:off x="768096" y="4850110"/>
+            <a:off x="768096" y="5310480"/>
             <a:ext cx="10655503" cy="214300"/>
           </a:xfrm>
           <a:prstGeom prst="rect">
@@ -2078,48 +2078,6 @@
               <a:t>1. [item pertama]   2. [item kedua]   3. [item ketiga] ...</a:t>
             </a:r>
             <a:endParaRPr lang="en-US" sz="1100" dirty="0"/>
-          </a:p>
-        </p:txBody>
-      </p:sp>
-      <p:sp>
-        <p:nvSpPr>
-          <p:cNvPr id="17" name="Text 15"/>
-          <p:cNvSpPr/>
-          <p:nvPr/>
-        </p:nvSpPr>
-        <p:spPr>
-          <a:xfrm>
-            <a:off x="548640" y="5521609"/>
-            <a:ext cx="11094415" cy="239776"/>
-          </a:xfrm>
-          <a:prstGeom prst="rect">
-            <a:avLst/>
-          </a:prstGeom>
-          <a:noFill/>
-          <a:ln/>
-        </p:spPr>
-        <p:txBody>
-          <a:bodyPr wrap="square" lIns="0" tIns="0" rIns="0" bIns="0" rtlCol="0" anchor="t"/>
-          <a:lstStyle/>
-          <a:p>
-            <a:pPr indent="0" marL="0">
-              <a:lnSpc>
-                <a:spcPct val="128000"/>
-              </a:lnSpc>
-              <a:buNone/>
-            </a:pPr>
-            <a:r>
-              <a:rPr lang="en-US" sz="1250" dirty="0">
-                <a:solidFill>
-                  <a:srgbClr val="6B7280"/>
-                </a:solidFill>
-                <a:latin typeface="Helvetica" pitchFamily="34" charset="0"/>
-                <a:ea typeface="Helvetica" pitchFamily="34" charset="-122"/>
-                <a:cs typeface="Helvetica" pitchFamily="34" charset="-120"/>
-              </a:rPr>
-              <a:t>20 produk → 5 menit. Bandingkan: cara biasa 20 prompt terpisah = 40 menit. Batch prompting = 1 prompt, 5 menit.</a:t>
-            </a:r>
-            <a:endParaRPr lang="en-US" sz="1250" dirty="0"/>
           </a:p>
         </p:txBody>
       </p:sp>

</xml_diff>